<commit_message>
Show branch 0.9.0 on the phase 1 slide of the Benchmarking Providers Roadmap
Co-Authored-By: Claude Opus 5.5 <noreply@anthropic.com>
</commit_message>
<xml_diff>
--- a/src/web_interface/static/presentations/benchmarking-providers.pptx
+++ b/src/web_interface/static/presentations/benchmarking-providers.pptx
@@ -128,7 +128,7 @@
   <p:extLst>
     <p:ext uri="{521415D9-36F7-43E2-AB2F-B90AF26B5E84}">
       <p14:sectionLst xmlns:p14="http://schemas.microsoft.com/office/powerpoint/2010/main">
-        <p14:section name="Introduction" id="{cfbc49c1-4b9b-65ac-482f-6a0629e729d8}">
+        <p14:section name="Introduction" id="{d7e495d5-1a99-b3d8-7c85-075ed873465b}">
           <p14:sldIdLst>
             <p14:sldId id="256"/>
             <p14:sldId id="257"/>
@@ -137,7 +137,7 @@
             <p14:sldId id="260"/>
           </p14:sldIdLst>
         </p14:section>
-        <p14:section name="Multi-provider architecture" id="{1315b698-b210-a870-d67f-81b8fc8612f1}">
+        <p14:section name="Multi-provider architecture" id="{4d6b70cf-c272-e96e-ad74-7b61c384e555}">
           <p14:sldIdLst>
             <p14:sldId id="261"/>
             <p14:sldId id="262"/>
@@ -149,14 +149,14 @@
             <p14:sldId id="268"/>
           </p14:sldIdLst>
         </p14:section>
-        <p14:section name="Internal architecture" id="{74d464c5-1ad1-bc4b-b2a8-eee7dfe3cc9d}">
+        <p14:section name="Internal architecture" id="{94ff5c58-b5e7-9600-b929-19a6c87f8144}">
           <p14:sldIdLst>
             <p14:sldId id="269"/>
             <p14:sldId id="270"/>
             <p14:sldId id="271"/>
           </p14:sldIdLst>
         </p14:section>
-        <p14:section name="Cloud deployment" id="{3f71cbd8-d787-86f8-a511-c01e0bd5896e}">
+        <p14:section name="Cloud deployment" id="{b6ef2ae5-ed41-7791-ea1a-33a020703559}">
           <p14:sldIdLst>
             <p14:sldId id="272"/>
             <p14:sldId id="273"/>
@@ -165,7 +165,7 @@
             <p14:sldId id="276"/>
           </p14:sldIdLst>
         </p14:section>
-        <p14:section name="Next step" id="{d74ce0e9-6fdc-242e-1fca-63516f5c611f}">
+        <p14:section name="Next step" id="{f1f20123-2c36-4efd-becd-b07929bd5815}">
           <p14:sldIdLst>
             <p14:sldId id="277"/>
           </p14:sldIdLst>
@@ -1542,7 +1542,7 @@
           <a:p>
             <a:r>
               <a:rPr lang="en-US" dirty="0"/>
-              <a:t>Today the tool is complete, but everything is written in NetCheck names and values: ingestion, the Scoring formulas, the PPT templates, the NQ definition and the radio tables of Network Insights. The figures come from the repository (branch 0.8.7) and the UK workspace.</a:t>
+              <a:t>Today the tool is complete, but everything is written in NetCheck names and values: ingestion, the Scoring formulas, the PPT templates, the NQ definition and the radio tables of Network Insights. The figures come from the repository (branch 0.9.0) and the UK workspace.</a:t>
             </a:r>
             <a:endParaRPr lang="en-US" dirty="0"/>
           </a:p>

</xml_diff>